<commit_message>
Final hackathon submission: AI Auto-Explain, OCR demo, Email Notifications, Dynamic Tables, Batch SPs, data-grounded AI Chat, 10 Tasks, CSV export, i18n, security hardening. 27 SPs, 8 UDFs, 3 DTs, 10 Tasks. Built 100%% with CoCo CLI.
</commit_message>
<xml_diff>
--- a/VF_Logistics_Presentation.pptx
+++ b/VF_Logistics_Presentation.pptx
@@ -22,6 +22,7 @@
     <p:sldId id="270" r:id="rId21"/>
     <p:sldId id="271" r:id="rId22"/>
     <p:sldId id="272" r:id="rId23"/>
+    <p:sldId id="273" r:id="rId24"/>
   </p:sldIdLst>
   <p:sldSz cx="9144000" cy="6858000" type="screen4x3"/>
   <p:notesSz cx="6858000" cy="9144000"/>
@@ -3120,7 +3121,7 @@
         </p:nvSpPr>
         <p:spPr>
           <a:xfrm>
-            <a:off x="731520" y="1828800"/>
+            <a:off x="731520" y="1645920"/>
             <a:ext cx="7772400" cy="731520"/>
           </a:xfrm>
           <a:prstGeom prst="rect">
@@ -3155,7 +3156,7 @@
         </p:nvSpPr>
         <p:spPr>
           <a:xfrm>
-            <a:off x="731520" y="2743200"/>
+            <a:off x="731520" y="2560320"/>
             <a:ext cx="7772400" cy="4572000"/>
           </a:xfrm>
           <a:prstGeom prst="rect">
@@ -3173,14 +3174,14 @@
               <a:spcAft>
                 <a:spcPts val="600"/>
               </a:spcAft>
-              <a:defRPr sz="2400" b="0">
+              <a:defRPr sz="2800" b="0">
                 <a:solidFill>
                   <a:srgbClr val="FFFFFF"/>
                 </a:solidFill>
               </a:defRPr>
             </a:pPr>
             <a:r>
-              <a:t>AI-Powered Enterprise Seaport Platform</a:t>
+              <a:t>Document to SAP in 10 Seconds</a:t>
             </a:r>
           </a:p>
         </p:txBody>
@@ -3193,7 +3194,7 @@
         </p:nvSpPr>
         <p:spPr>
           <a:xfrm>
-            <a:off x="731520" y="3840480"/>
+            <a:off x="731520" y="3657600"/>
             <a:ext cx="7772400" cy="4572000"/>
           </a:xfrm>
           <a:prstGeom prst="rect">
@@ -3218,7 +3219,7 @@
               </a:defRPr>
             </a:pPr>
             <a:r>
-              <a:t>Team SORA</a:t>
+              <a:t>Track 1: Workflow Automation</a:t>
             </a:r>
           </a:p>
           <a:p>
@@ -3233,7 +3234,34 @@
               </a:defRPr>
             </a:pPr>
             <a:r>
-              <a:t>Built 100% with Snowflake CoCo CLI (Cortex Code)</a:t>
+              <a:t>From document chaos to fully automated ERP posting</a:t>
+            </a:r>
+          </a:p>
+          <a:p>
+            <a:pPr>
+              <a:spcAft>
+                <a:spcPts val="600"/>
+              </a:spcAft>
+              <a:defRPr sz="1400" b="0">
+                <a:solidFill>
+                  <a:srgbClr val="999999"/>
+                </a:solidFill>
+              </a:defRPr>
+            </a:pPr>
+          </a:p>
+          <a:p>
+            <a:pPr>
+              <a:spcAft>
+                <a:spcPts val="600"/>
+              </a:spcAft>
+              <a:defRPr sz="1400" b="0">
+                <a:solidFill>
+                  <a:srgbClr val="999999"/>
+                </a:solidFill>
+              </a:defRPr>
+            </a:pPr>
+            <a:r>
+              <a:t>Team SORA | Built 100% with Snowflake CoCo CLI</a:t>
             </a:r>
           </a:p>
           <a:p>
@@ -3521,20 +3549,402 @@
               </a:defRPr>
             </a:pPr>
             <a:r>
-              <a:t>Marketplace Integration: Marine Weather</a:t>
-            </a:r>
-          </a:p>
-        </p:txBody>
-      </p:sp>
-      <p:sp>
-        <p:nvSpPr>
-          <p:cNvPr id="3" name="TextBox 2"/>
+              <a:t>Marketplace: 3 Live Data Sources (Zero ETL)</a:t>
+            </a:r>
+          </a:p>
+        </p:txBody>
+      </p:sp>
+      <p:graphicFrame>
+        <p:nvGraphicFramePr>
+          <p:cNvPr id="3" name="Table 2"/>
+          <p:cNvGraphicFramePr>
+            <a:graphicFrameLocks noGrp="1"/>
+          </p:cNvGraphicFramePr>
+          <p:nvPr/>
+        </p:nvGraphicFramePr>
+        <p:xfrm>
+          <a:off x="731520" y="1645920"/>
+          <a:ext cx="7772400" cy="1828800"/>
+        </p:xfrm>
+        <a:graphic>
+          <a:graphicData uri="http://schemas.openxmlformats.org/drawingml/2006/table">
+            <a:tbl>
+              <a:tblPr firstRow="1" bandRow="1">
+                <a:tableStyleId>{5C22544A-7EE6-4342-B048-85BDC9FD1C3A}</a:tableStyleId>
+              </a:tblPr>
+              <a:tblGrid>
+                <a:gridCol w="2560320"/>
+                <a:gridCol w="2926080"/>
+                <a:gridCol w="2286000"/>
+              </a:tblGrid>
+              <a:tr h="365760">
+                <a:tc>
+                  <a:txBody>
+                    <a:bodyPr/>
+                    <a:lstStyle/>
+                    <a:p>
+                      <a:pPr>
+                        <a:defRPr sz="1100" b="1">
+                          <a:solidFill>
+                            <a:srgbClr val="000000"/>
+                          </a:solidFill>
+                        </a:defRPr>
+                      </a:pPr>
+                      <a:r>
+                        <a:t>Source</a:t>
+                      </a:r>
+                    </a:p>
+                  </a:txBody>
+                  <a:tcPr>
+                    <a:solidFill>
+                      <a:srgbClr val="29B5E8"/>
+                    </a:solidFill>
+                  </a:tcPr>
+                </a:tc>
+                <a:tc>
+                  <a:txBody>
+                    <a:bodyPr/>
+                    <a:lstStyle/>
+                    <a:p>
+                      <a:pPr>
+                        <a:defRPr sz="1100" b="1">
+                          <a:solidFill>
+                            <a:srgbClr val="000000"/>
+                          </a:solidFill>
+                        </a:defRPr>
+                      </a:pPr>
+                      <a:r>
+                        <a:t>Data</a:t>
+                      </a:r>
+                    </a:p>
+                  </a:txBody>
+                  <a:tcPr>
+                    <a:solidFill>
+                      <a:srgbClr val="29B5E8"/>
+                    </a:solidFill>
+                  </a:tcPr>
+                </a:tc>
+                <a:tc>
+                  <a:txBody>
+                    <a:bodyPr/>
+                    <a:lstStyle/>
+                    <a:p>
+                      <a:pPr>
+                        <a:defRPr sz="1100" b="1">
+                          <a:solidFill>
+                            <a:srgbClr val="000000"/>
+                          </a:solidFill>
+                        </a:defRPr>
+                      </a:pPr>
+                      <a:r>
+                        <a:t>Workflow Use</a:t>
+                      </a:r>
+                    </a:p>
+                  </a:txBody>
+                  <a:tcPr>
+                    <a:solidFill>
+                      <a:srgbClr val="29B5E8"/>
+                    </a:solidFill>
+                  </a:tcPr>
+                </a:tc>
+              </a:tr>
+              <a:tr h="365760">
+                <a:tc>
+                  <a:txBody>
+                    <a:bodyPr/>
+                    <a:lstStyle/>
+                    <a:p>
+                      <a:pPr>
+                        <a:defRPr sz="1000">
+                          <a:solidFill>
+                            <a:srgbClr val="E0E0E0"/>
+                          </a:solidFill>
+                        </a:defRPr>
+                      </a:pPr>
+                      <a:r>
+                        <a:t>Pelmorex Weather</a:t>
+                      </a:r>
+                    </a:p>
+                  </a:txBody>
+                  <a:tcPr>
+                    <a:solidFill>
+                      <a:srgbClr val="1A1F2E"/>
+                    </a:solidFill>
+                  </a:tcPr>
+                </a:tc>
+                <a:tc>
+                  <a:txBody>
+                    <a:bodyPr/>
+                    <a:lstStyle/>
+                    <a:p>
+                      <a:pPr>
+                        <a:defRPr sz="1000">
+                          <a:solidFill>
+                            <a:srgbClr val="E0E0E0"/>
+                          </a:solidFill>
+                        </a:defRPr>
+                      </a:pPr>
+                      <a:r>
+                        <a:t>3,324 port forecasts</a:t>
+                      </a:r>
+                    </a:p>
+                  </a:txBody>
+                  <a:tcPr>
+                    <a:solidFill>
+                      <a:srgbClr val="1A1F2E"/>
+                    </a:solidFill>
+                  </a:tcPr>
+                </a:tc>
+                <a:tc>
+                  <a:txBody>
+                    <a:bodyPr/>
+                    <a:lstStyle/>
+                    <a:p>
+                      <a:pPr>
+                        <a:defRPr sz="1000">
+                          <a:solidFill>
+                            <a:srgbClr val="E0E0E0"/>
+                          </a:solidFill>
+                        </a:defRPr>
+                      </a:pPr>
+                      <a:r>
+                        <a:t>Delay alerts</a:t>
+                      </a:r>
+                    </a:p>
+                  </a:txBody>
+                  <a:tcPr>
+                    <a:solidFill>
+                      <a:srgbClr val="1A1F2E"/>
+                    </a:solidFill>
+                  </a:tcPr>
+                </a:tc>
+              </a:tr>
+              <a:tr h="365760">
+                <a:tc>
+                  <a:txBody>
+                    <a:bodyPr/>
+                    <a:lstStyle/>
+                    <a:p>
+                      <a:pPr>
+                        <a:defRPr sz="1000">
+                          <a:solidFill>
+                            <a:srgbClr val="E0E0E0"/>
+                          </a:solidFill>
+                        </a:defRPr>
+                      </a:pPr>
+                      <a:r>
+                        <a:t>Public Free - FX</a:t>
+                      </a:r>
+                    </a:p>
+                  </a:txBody>
+                  <a:tcPr>
+                    <a:solidFill>
+                      <a:srgbClr val="1A1F2E"/>
+                    </a:solidFill>
+                  </a:tcPr>
+                </a:tc>
+                <a:tc>
+                  <a:txBody>
+                    <a:bodyPr/>
+                    <a:lstStyle/>
+                    <a:p>
+                      <a:pPr>
+                        <a:defRPr sz="1000">
+                          <a:solidFill>
+                            <a:srgbClr val="E0E0E0"/>
+                          </a:solidFill>
+                        </a:defRPr>
+                      </a:pPr>
+                      <a:r>
+                        <a:t>12 currency pairs (live)</a:t>
+                      </a:r>
+                    </a:p>
+                  </a:txBody>
+                  <a:tcPr>
+                    <a:solidFill>
+                      <a:srgbClr val="1A1F2E"/>
+                    </a:solidFill>
+                  </a:tcPr>
+                </a:tc>
+                <a:tc>
+                  <a:txBody>
+                    <a:bodyPr/>
+                    <a:lstStyle/>
+                    <a:p>
+                      <a:pPr>
+                        <a:defRPr sz="1000">
+                          <a:solidFill>
+                            <a:srgbClr val="E0E0E0"/>
+                          </a:solidFill>
+                        </a:defRPr>
+                      </a:pPr>
+                      <a:r>
+                        <a:t>SAP charge conversion</a:t>
+                      </a:r>
+                    </a:p>
+                  </a:txBody>
+                  <a:tcPr>
+                    <a:solidFill>
+                      <a:srgbClr val="1A1F2E"/>
+                    </a:solidFill>
+                  </a:tcPr>
+                </a:tc>
+              </a:tr>
+              <a:tr h="365760">
+                <a:tc>
+                  <a:txBody>
+                    <a:bodyPr/>
+                    <a:lstStyle/>
+                    <a:p>
+                      <a:pPr>
+                        <a:defRPr sz="1000">
+                          <a:solidFill>
+                            <a:srgbClr val="E0E0E0"/>
+                          </a:solidFill>
+                        </a:defRPr>
+                      </a:pPr>
+                      <a:r>
+                        <a:t>Public Free - WTO</a:t>
+                      </a:r>
+                    </a:p>
+                  </a:txBody>
+                  <a:tcPr>
+                    <a:solidFill>
+                      <a:srgbClr val="1A1F2E"/>
+                    </a:solidFill>
+                  </a:tcPr>
+                </a:tc>
+                <a:tc>
+                  <a:txBody>
+                    <a:bodyPr/>
+                    <a:lstStyle/>
+                    <a:p>
+                      <a:pPr>
+                        <a:defRPr sz="1000">
+                          <a:solidFill>
+                            <a:srgbClr val="E0E0E0"/>
+                          </a:solidFill>
+                        </a:defRPr>
+                      </a:pPr>
+                      <a:r>
+                        <a:t>VN + 7 partner trade stats</a:t>
+                      </a:r>
+                    </a:p>
+                  </a:txBody>
+                  <a:tcPr>
+                    <a:solidFill>
+                      <a:srgbClr val="1A1F2E"/>
+                    </a:solidFill>
+                  </a:tcPr>
+                </a:tc>
+                <a:tc>
+                  <a:txBody>
+                    <a:bodyPr/>
+                    <a:lstStyle/>
+                    <a:p>
+                      <a:pPr>
+                        <a:defRPr sz="1000">
+                          <a:solidFill>
+                            <a:srgbClr val="E0E0E0"/>
+                          </a:solidFill>
+                        </a:defRPr>
+                      </a:pPr>
+                      <a:r>
+                        <a:t>Route demand</a:t>
+                      </a:r>
+                    </a:p>
+                  </a:txBody>
+                  <a:tcPr>
+                    <a:solidFill>
+                      <a:srgbClr val="1A1F2E"/>
+                    </a:solidFill>
+                  </a:tcPr>
+                </a:tc>
+              </a:tr>
+              <a:tr h="365760">
+                <a:tc>
+                  <a:txBody>
+                    <a:bodyPr/>
+                    <a:lstStyle/>
+                    <a:p>
+                      <a:pPr>
+                        <a:defRPr sz="1000">
+                          <a:solidFill>
+                            <a:srgbClr val="E0E0E0"/>
+                          </a:solidFill>
+                        </a:defRPr>
+                      </a:pPr>
+                      <a:r>
+                        <a:t>Public Free - ITA</a:t>
+                      </a:r>
+                    </a:p>
+                  </a:txBody>
+                  <a:tcPr>
+                    <a:solidFill>
+                      <a:srgbClr val="1A1F2E"/>
+                    </a:solidFill>
+                  </a:tcPr>
+                </a:tc>
+                <a:tc>
+                  <a:txBody>
+                    <a:bodyPr/>
+                    <a:lstStyle/>
+                    <a:p>
+                      <a:pPr>
+                        <a:defRPr sz="1000">
+                          <a:solidFill>
+                            <a:srgbClr val="E0E0E0"/>
+                          </a:solidFill>
+                        </a:defRPr>
+                      </a:pPr>
+                      <a:r>
+                        <a:t>1,816 restricted entities</a:t>
+                      </a:r>
+                    </a:p>
+                  </a:txBody>
+                  <a:tcPr>
+                    <a:solidFill>
+                      <a:srgbClr val="1A1F2E"/>
+                    </a:solidFill>
+                  </a:tcPr>
+                </a:tc>
+                <a:tc>
+                  <a:txBody>
+                    <a:bodyPr/>
+                    <a:lstStyle/>
+                    <a:p>
+                      <a:pPr>
+                        <a:defRPr sz="1000">
+                          <a:solidFill>
+                            <a:srgbClr val="E0E0E0"/>
+                          </a:solidFill>
+                        </a:defRPr>
+                      </a:pPr>
+                      <a:r>
+                        <a:t>Sanction screening</a:t>
+                      </a:r>
+                    </a:p>
+                  </a:txBody>
+                  <a:tcPr>
+                    <a:solidFill>
+                      <a:srgbClr val="1A1F2E"/>
+                    </a:solidFill>
+                  </a:tcPr>
+                </a:tc>
+              </a:tr>
+            </a:tbl>
+          </a:graphicData>
+        </a:graphic>
+      </p:graphicFrame>
+      <p:sp>
+        <p:nvSpPr>
+          <p:cNvPr id="4" name="TextBox 3"/>
           <p:cNvSpPr txBox="1"/>
           <p:nvPr/>
         </p:nvSpPr>
         <p:spPr>
           <a:xfrm>
-            <a:off x="731520" y="1371600"/>
+            <a:off x="731520" y="4114800"/>
             <a:ext cx="7772400" cy="4572000"/>
           </a:xfrm>
           <a:prstGeom prst="rect">
@@ -3552,112 +3962,14 @@
               <a:spcAft>
                 <a:spcPts val="600"/>
               </a:spcAft>
-              <a:defRPr sz="1300" b="0">
+              <a:defRPr sz="1200" b="0">
                 <a:solidFill>
                   <a:srgbClr val="29B5E8"/>
                 </a:solidFill>
               </a:defRPr>
             </a:pPr>
             <a:r>
-              <a:t>Source: Pelmorex Global Weather Data (Snowflake Marketplace)</a:t>
-            </a:r>
-          </a:p>
-        </p:txBody>
-      </p:sp>
-      <p:sp>
-        <p:nvSpPr>
-          <p:cNvPr id="4" name="TextBox 3"/>
-          <p:cNvSpPr txBox="1"/>
-          <p:nvPr/>
-        </p:nvSpPr>
-        <p:spPr>
-          <a:xfrm>
-            <a:off x="731520" y="2286000"/>
-            <a:ext cx="7772400" cy="4572000"/>
-          </a:xfrm>
-          <a:prstGeom prst="rect">
-            <a:avLst/>
-          </a:prstGeom>
-          <a:noFill/>
-        </p:spPr>
-        <p:txBody>
-          <a:bodyPr wrap="square">
-            <a:spAutoFit/>
-          </a:bodyPr>
-          <a:lstStyle/>
-          <a:p>
-            <a:pPr>
-              <a:spcAft>
-                <a:spcPts val="800"/>
-              </a:spcAft>
-              <a:defRPr sz="1500">
-                <a:solidFill>
-                  <a:srgbClr val="E0E0E0"/>
-                </a:solidFill>
-              </a:defRPr>
-            </a:pPr>
-            <a:r>
-              <a:t>V_PORT_WEATHER_FORECAST view joins weather with PORT_MASTER</a:t>
-            </a:r>
-          </a:p>
-          <a:p>
-            <a:pPr>
-              <a:spcAft>
-                <a:spcPts val="800"/>
-              </a:spcAft>
-              <a:defRPr sz="1500">
-                <a:solidFill>
-                  <a:srgbClr val="E0E0E0"/>
-                </a:solidFill>
-              </a:defRPr>
-            </a:pPr>
-            <a:r>
-              <a:t>7-day forecast with impact classification</a:t>
-            </a:r>
-          </a:p>
-          <a:p>
-            <a:pPr>
-              <a:spcAft>
-                <a:spcPts val="800"/>
-              </a:spcAft>
-              <a:defRPr sz="1500">
-                <a:solidFill>
-                  <a:srgbClr val="E0E0E0"/>
-                </a:solidFill>
-              </a:defRPr>
-            </a:pPr>
-            <a:r>
-              <a:t>Weather Impact: Good / Rain Expected / Strong Wind / Heavy Rain</a:t>
-            </a:r>
-          </a:p>
-          <a:p>
-            <a:pPr>
-              <a:spcAft>
-                <a:spcPts val="800"/>
-              </a:spcAft>
-              <a:defRPr sz="1500">
-                <a:solidFill>
-                  <a:srgbClr val="E0E0E0"/>
-                </a:solidFill>
-              </a:defRPr>
-            </a:pPr>
-            <a:r>
-              <a:t>Proactive alerts for severe weather at destination ports</a:t>
-            </a:r>
-          </a:p>
-          <a:p>
-            <a:pPr>
-              <a:spcAft>
-                <a:spcPts val="800"/>
-              </a:spcAft>
-              <a:defRPr sz="1500">
-                <a:solidFill>
-                  <a:srgbClr val="E0E0E0"/>
-                </a:solidFill>
-              </a:defRPr>
-            </a:pPr>
-            <a:r>
-              <a:t>Zero-copy data sharing - always fresh, no ETL needed</a:t>
+              <a:t>All free | Auto-refresh | Zero infrastructure | Zero-copy sharing</a:t>
             </a:r>
           </a:p>
         </p:txBody>
@@ -4478,30 +4790,30 @@
                         </a:defRPr>
                       </a:pPr>
                       <a:r>
-                        <a:t>Reliability</a:t>
-                      </a:r>
-                    </a:p>
-                  </a:txBody>
-                  <a:tcPr>
-                    <a:solidFill>
-                      <a:srgbClr val="1A1F2E"/>
-                    </a:solidFill>
-                  </a:tcPr>
-                </a:tc>
-                <a:tc>
-                  <a:txBody>
-                    <a:bodyPr/>
-                    <a:lstStyle/>
-                    <a:p>
-                      <a:pPr>
-                        <a:defRPr sz="1000">
-                          <a:solidFill>
-                            <a:srgbClr val="E0E0E0"/>
-                          </a:solidFill>
-                        </a:defRPr>
-                      </a:pPr>
-                      <a:r>
-                        <a:t>Exponential backoff retry (1s, 2s, 4s)</a:t>
+                        <a:t>Agent Data Policy</a:t>
+                      </a:r>
+                    </a:p>
+                  </a:txBody>
+                  <a:tcPr>
+                    <a:solidFill>
+                      <a:srgbClr val="1A1F2E"/>
+                    </a:solidFill>
+                  </a:tcPr>
+                </a:tc>
+                <a:tc>
+                  <a:txBody>
+                    <a:bodyPr/>
+                    <a:lstStyle/>
+                    <a:p>
+                      <a:pPr>
+                        <a:defRPr sz="1000">
+                          <a:solidFill>
+                            <a:srgbClr val="E0E0E0"/>
+                          </a:solidFill>
+                        </a:defRPr>
+                      </a:pPr>
+                      <a:r>
+                        <a:t>Specific lookup OK, bulk export BLOCKED</a:t>
                       </a:r>
                     </a:p>
                   </a:txBody>
@@ -4526,30 +4838,30 @@
                         </a:defRPr>
                       </a:pPr>
                       <a:r>
-                        <a:t>Data Access</a:t>
-                      </a:r>
-                    </a:p>
-                  </a:txBody>
-                  <a:tcPr>
-                    <a:solidFill>
-                      <a:srgbClr val="1A1F2E"/>
-                    </a:solidFill>
-                  </a:tcPr>
-                </a:tc>
-                <a:tc>
-                  <a:txBody>
-                    <a:bodyPr/>
-                    <a:lstStyle/>
-                    <a:p>
-                      <a:pPr>
-                        <a:defRPr sz="1000">
-                          <a:solidFill>
-                            <a:srgbClr val="E0E0E0"/>
-                          </a:solidFill>
-                        </a:defRPr>
-                      </a:pPr>
-                      <a:r>
-                        <a:t>Procedures only - no direct table modification</a:t>
+                        <a:t>Anti-Scraping</a:t>
+                      </a:r>
+                    </a:p>
+                  </a:txBody>
+                  <a:tcPr>
+                    <a:solidFill>
+                      <a:srgbClr val="1A1F2E"/>
+                    </a:solidFill>
+                  </a:tcPr>
+                </a:tc>
+                <a:tc>
+                  <a:txBody>
+                    <a:bodyPr/>
+                    <a:lstStyle/>
+                    <a:p>
+                      <a:pPr>
+                        <a:defRPr sz="1000">
+                          <a:solidFill>
+                            <a:srgbClr val="E0E0E0"/>
+                          </a:solidFill>
+                        </a:defRPr>
+                      </a:pPr>
+                      <a:r>
+                        <a:t>Broad queries return summaries only</a:t>
                       </a:r>
                     </a:p>
                   </a:txBody>
@@ -4620,7 +4932,7 @@
               </a:defRPr>
             </a:pPr>
             <a:r>
-              <a:t>Business Impact</a:t>
+              <a:t>AI Agent: Professional Logistics Search</a:t>
             </a:r>
           </a:p>
         </p:txBody>
@@ -4645,9 +4957,7 @@
               </a:tblPr>
               <a:tblGrid>
                 <a:gridCol w="2286000"/>
-                <a:gridCol w="1828800"/>
-                <a:gridCol w="1828800"/>
-                <a:gridCol w="1828800"/>
+                <a:gridCol w="5486400"/>
               </a:tblGrid>
               <a:tr h="365760">
                 <a:tc>
@@ -4663,7 +4973,7 @@
                         </a:defRPr>
                       </a:pPr>
                       <a:r>
-                        <a:t>Metric</a:t>
+                        <a:t>Search Type</a:t>
                       </a:r>
                     </a:p>
                   </a:txBody>
@@ -4686,53 +4996,7 @@
                         </a:defRPr>
                       </a:pPr>
                       <a:r>
-                        <a:t>Before</a:t>
-                      </a:r>
-                    </a:p>
-                  </a:txBody>
-                  <a:tcPr>
-                    <a:solidFill>
-                      <a:srgbClr val="29B5E8"/>
-                    </a:solidFill>
-                  </a:tcPr>
-                </a:tc>
-                <a:tc>
-                  <a:txBody>
-                    <a:bodyPr/>
-                    <a:lstStyle/>
-                    <a:p>
-                      <a:pPr>
-                        <a:defRPr sz="1100" b="1">
-                          <a:solidFill>
-                            <a:srgbClr val="000000"/>
-                          </a:solidFill>
-                        </a:defRPr>
-                      </a:pPr>
-                      <a:r>
-                        <a:t>After</a:t>
-                      </a:r>
-                    </a:p>
-                  </a:txBody>
-                  <a:tcPr>
-                    <a:solidFill>
-                      <a:srgbClr val="29B5E8"/>
-                    </a:solidFill>
-                  </a:tcPr>
-                </a:tc>
-                <a:tc>
-                  <a:txBody>
-                    <a:bodyPr/>
-                    <a:lstStyle/>
-                    <a:p>
-                      <a:pPr>
-                        <a:defRPr sz="1100" b="1">
-                          <a:solidFill>
-                            <a:srgbClr val="000000"/>
-                          </a:solidFill>
-                        </a:defRPr>
-                      </a:pPr>
-                      <a:r>
-                        <a:t>Improvement</a:t>
+                        <a:t>Examples</a:t>
                       </a:r>
                     </a:p>
                   </a:txBody>
@@ -4757,76 +5021,30 @@
                         </a:defRPr>
                       </a:pPr>
                       <a:r>
-                        <a:t>Classification time</a:t>
-                      </a:r>
-                    </a:p>
-                  </a:txBody>
-                  <a:tcPr>
-                    <a:solidFill>
-                      <a:srgbClr val="1A1F2E"/>
-                    </a:solidFill>
-                  </a:tcPr>
-                </a:tc>
-                <a:tc>
-                  <a:txBody>
-                    <a:bodyPr/>
-                    <a:lstStyle/>
-                    <a:p>
-                      <a:pPr>
-                        <a:defRPr sz="1000">
-                          <a:solidFill>
-                            <a:srgbClr val="E0E0E0"/>
-                          </a:solidFill>
-                        </a:defRPr>
-                      </a:pPr>
-                      <a:r>
-                        <a:t>15-30 min</a:t>
-                      </a:r>
-                    </a:p>
-                  </a:txBody>
-                  <a:tcPr>
-                    <a:solidFill>
-                      <a:srgbClr val="1A1F2E"/>
-                    </a:solidFill>
-                  </a:tcPr>
-                </a:tc>
-                <a:tc>
-                  <a:txBody>
-                    <a:bodyPr/>
-                    <a:lstStyle/>
-                    <a:p>
-                      <a:pPr>
-                        <a:defRPr sz="1000">
-                          <a:solidFill>
-                            <a:srgbClr val="E0E0E0"/>
-                          </a:solidFill>
-                        </a:defRPr>
-                      </a:pPr>
-                      <a:r>
-                        <a:t>2-3 sec</a:t>
-                      </a:r>
-                    </a:p>
-                  </a:txBody>
-                  <a:tcPr>
-                    <a:solidFill>
-                      <a:srgbClr val="1A1F2E"/>
-                    </a:solidFill>
-                  </a:tcPr>
-                </a:tc>
-                <a:tc>
-                  <a:txBody>
-                    <a:bodyPr/>
-                    <a:lstStyle/>
-                    <a:p>
-                      <a:pPr>
-                        <a:defRPr sz="1000">
-                          <a:solidFill>
-                            <a:srgbClr val="E0E0E0"/>
-                          </a:solidFill>
-                        </a:defRPr>
-                      </a:pPr>
-                      <a:r>
-                        <a:t>99.7% faster</a:t>
+                        <a:t>By Identifier</a:t>
+                      </a:r>
+                    </a:p>
+                  </a:txBody>
+                  <a:tcPr>
+                    <a:solidFill>
+                      <a:srgbClr val="1A1F2E"/>
+                    </a:solidFill>
+                  </a:tcPr>
+                </a:tc>
+                <a:tc>
+                  <a:txBody>
+                    <a:bodyPr/>
+                    <a:lstStyle/>
+                    <a:p>
+                      <a:pPr>
+                        <a:defRPr sz="1000">
+                          <a:solidFill>
+                            <a:srgbClr val="E0E0E0"/>
+                          </a:solidFill>
+                        </a:defRPr>
+                      </a:pPr>
+                      <a:r>
+                        <a:t>B/L number, Container ISO, Booking ref, IMO</a:t>
                       </a:r>
                     </a:p>
                   </a:txBody>
@@ -4851,76 +5069,30 @@
                         </a:defRPr>
                       </a:pPr>
                       <a:r>
-                        <a:t>Compliance coverage</a:t>
-                      </a:r>
-                    </a:p>
-                  </a:txBody>
-                  <a:tcPr>
-                    <a:solidFill>
-                      <a:srgbClr val="1A1F2E"/>
-                    </a:solidFill>
-                  </a:tcPr>
-                </a:tc>
-                <a:tc>
-                  <a:txBody>
-                    <a:bodyPr/>
-                    <a:lstStyle/>
-                    <a:p>
-                      <a:pPr>
-                        <a:defRPr sz="1000">
-                          <a:solidFill>
-                            <a:srgbClr val="E0E0E0"/>
-                          </a:solidFill>
-                        </a:defRPr>
-                      </a:pPr>
-                      <a:r>
-                        <a:t>60% manual</a:t>
-                      </a:r>
-                    </a:p>
-                  </a:txBody>
-                  <a:tcPr>
-                    <a:solidFill>
-                      <a:srgbClr val="1A1F2E"/>
-                    </a:solidFill>
-                  </a:tcPr>
-                </a:tc>
-                <a:tc>
-                  <a:txBody>
-                    <a:bodyPr/>
-                    <a:lstStyle/>
-                    <a:p>
-                      <a:pPr>
-                        <a:defRPr sz="1000">
-                          <a:solidFill>
-                            <a:srgbClr val="E0E0E0"/>
-                          </a:solidFill>
-                        </a:defRPr>
-                      </a:pPr>
-                      <a:r>
-                        <a:t>100% auto</a:t>
-                      </a:r>
-                    </a:p>
-                  </a:txBody>
-                  <a:tcPr>
-                    <a:solidFill>
-                      <a:srgbClr val="1A1F2E"/>
-                    </a:solidFill>
-                  </a:tcPr>
-                </a:tc>
-                <a:tc>
-                  <a:txBody>
-                    <a:bodyPr/>
-                    <a:lstStyle/>
-                    <a:p>
-                      <a:pPr>
-                        <a:defRPr sz="1000">
-                          <a:solidFill>
-                            <a:srgbClr val="E0E0E0"/>
-                          </a:solidFill>
-                        </a:defRPr>
-                      </a:pPr>
-                      <a:r>
-                        <a:t>Full coverage</a:t>
+                        <a:t>By Route</a:t>
+                      </a:r>
+                    </a:p>
+                  </a:txBody>
+                  <a:tcPr>
+                    <a:solidFill>
+                      <a:srgbClr val="1A1F2E"/>
+                    </a:solidFill>
+                  </a:tcPr>
+                </a:tc>
+                <a:tc>
+                  <a:txBody>
+                    <a:bodyPr/>
+                    <a:lstStyle/>
+                    <a:p>
+                      <a:pPr>
+                        <a:defRPr sz="1000">
+                          <a:solidFill>
+                            <a:srgbClr val="E0E0E0"/>
+                          </a:solidFill>
+                        </a:defRPr>
+                      </a:pPr>
+                      <a:r>
+                        <a:t>Port pair (VNSGN&gt;JPYOK), Country, Trade lane</a:t>
                       </a:r>
                     </a:p>
                   </a:txBody>
@@ -4945,76 +5117,30 @@
                         </a:defRPr>
                       </a:pPr>
                       <a:r>
-                        <a:t>Cross-check accuracy</a:t>
-                      </a:r>
-                    </a:p>
-                  </a:txBody>
-                  <a:tcPr>
-                    <a:solidFill>
-                      <a:srgbClr val="1A1F2E"/>
-                    </a:solidFill>
-                  </a:tcPr>
-                </a:tc>
-                <a:tc>
-                  <a:txBody>
-                    <a:bodyPr/>
-                    <a:lstStyle/>
-                    <a:p>
-                      <a:pPr>
-                        <a:defRPr sz="1000">
-                          <a:solidFill>
-                            <a:srgbClr val="E0E0E0"/>
-                          </a:solidFill>
-                        </a:defRPr>
-                      </a:pPr>
-                      <a:r>
-                        <a:t>Error-prone</a:t>
-                      </a:r>
-                    </a:p>
-                  </a:txBody>
-                  <a:tcPr>
-                    <a:solidFill>
-                      <a:srgbClr val="1A1F2E"/>
-                    </a:solidFill>
-                  </a:tcPr>
-                </a:tc>
-                <a:tc>
-                  <a:txBody>
-                    <a:bodyPr/>
-                    <a:lstStyle/>
-                    <a:p>
-                      <a:pPr>
-                        <a:defRPr sz="1000">
-                          <a:solidFill>
-                            <a:srgbClr val="E0E0E0"/>
-                          </a:solidFill>
-                        </a:defRPr>
-                      </a:pPr>
-                      <a:r>
-                        <a:t>Rule+AI hybrid</a:t>
-                      </a:r>
-                    </a:p>
-                  </a:txBody>
-                  <a:tcPr>
-                    <a:solidFill>
-                      <a:srgbClr val="1A1F2E"/>
-                    </a:solidFill>
-                  </a:tcPr>
-                </a:tc>
-                <a:tc>
-                  <a:txBody>
-                    <a:bodyPr/>
-                    <a:lstStyle/>
-                    <a:p>
-                      <a:pPr>
-                        <a:defRPr sz="1000">
-                          <a:solidFill>
-                            <a:srgbClr val="E0E0E0"/>
-                          </a:solidFill>
-                        </a:defRPr>
-                      </a:pPr>
-                      <a:r>
-                        <a:t>Zero missed</a:t>
+                        <a:t>By Party</a:t>
+                      </a:r>
+                    </a:p>
+                  </a:txBody>
+                  <a:tcPr>
+                    <a:solidFill>
+                      <a:srgbClr val="1A1F2E"/>
+                    </a:solidFill>
+                  </a:tcPr>
+                </a:tc>
+                <a:tc>
+                  <a:txBody>
+                    <a:bodyPr/>
+                    <a:lstStyle/>
+                    <a:p>
+                      <a:pPr>
+                        <a:defRPr sz="1000">
+                          <a:solidFill>
+                            <a:srgbClr val="E0E0E0"/>
+                          </a:solidFill>
+                        </a:defRPr>
+                      </a:pPr>
+                      <a:r>
+                        <a:t>Shipper, Consignee, Carrier name</a:t>
                       </a:r>
                     </a:p>
                   </a:txBody>
@@ -5039,76 +5165,30 @@
                         </a:defRPr>
                       </a:pPr>
                       <a:r>
-                        <a:t>Fraud detection</a:t>
-                      </a:r>
-                    </a:p>
-                  </a:txBody>
-                  <a:tcPr>
-                    <a:solidFill>
-                      <a:srgbClr val="1A1F2E"/>
-                    </a:solidFill>
-                  </a:tcPr>
-                </a:tc>
-                <a:tc>
-                  <a:txBody>
-                    <a:bodyPr/>
-                    <a:lstStyle/>
-                    <a:p>
-                      <a:pPr>
-                        <a:defRPr sz="1000">
-                          <a:solidFill>
-                            <a:srgbClr val="E0E0E0"/>
-                          </a:solidFill>
-                        </a:defRPr>
-                      </a:pPr>
-                      <a:r>
-                        <a:t>Reactive</a:t>
-                      </a:r>
-                    </a:p>
-                  </a:txBody>
-                  <a:tcPr>
-                    <a:solidFill>
-                      <a:srgbClr val="1A1F2E"/>
-                    </a:solidFill>
-                  </a:tcPr>
-                </a:tc>
-                <a:tc>
-                  <a:txBody>
-                    <a:bodyPr/>
-                    <a:lstStyle/>
-                    <a:p>
-                      <a:pPr>
-                        <a:defRPr sz="1000">
-                          <a:solidFill>
-                            <a:srgbClr val="E0E0E0"/>
-                          </a:solidFill>
-                        </a:defRPr>
-                      </a:pPr>
-                      <a:r>
-                        <a:t>Proactive</a:t>
-                      </a:r>
-                    </a:p>
-                  </a:txBody>
-                  <a:tcPr>
-                    <a:solidFill>
-                      <a:srgbClr val="1A1F2E"/>
-                    </a:solidFill>
-                  </a:tcPr>
-                </a:tc>
-                <a:tc>
-                  <a:txBody>
-                    <a:bodyPr/>
-                    <a:lstStyle/>
-                    <a:p>
-                      <a:pPr>
-                        <a:defRPr sz="1000">
-                          <a:solidFill>
-                            <a:srgbClr val="E0E0E0"/>
-                          </a:solidFill>
-                        </a:defRPr>
-                      </a:pPr>
-                      <a:r>
-                        <a:t>Early detection</a:t>
+                        <a:t>By Time</a:t>
+                      </a:r>
+                    </a:p>
+                  </a:txBody>
+                  <a:tcPr>
+                    <a:solidFill>
+                      <a:srgbClr val="1A1F2E"/>
+                    </a:solidFill>
+                  </a:tcPr>
+                </a:tc>
+                <a:tc>
+                  <a:txBody>
+                    <a:bodyPr/>
+                    <a:lstStyle/>
+                    <a:p>
+                      <a:pPr>
+                        <a:defRPr sz="1000">
+                          <a:solidFill>
+                            <a:srgbClr val="E0E0E0"/>
+                          </a:solidFill>
+                        </a:defRPr>
+                      </a:pPr>
+                      <a:r>
+                        <a:t>ETD/ETA range, Date of issue</a:t>
                       </a:r>
                     </a:p>
                   </a:txBody>
@@ -5133,76 +5213,30 @@
                         </a:defRPr>
                       </a:pPr>
                       <a:r>
-                        <a:t>AI cost per document</a:t>
-                      </a:r>
-                    </a:p>
-                  </a:txBody>
-                  <a:tcPr>
-                    <a:solidFill>
-                      <a:srgbClr val="1A1F2E"/>
-                    </a:solidFill>
-                  </a:tcPr>
-                </a:tc>
-                <a:tc>
-                  <a:txBody>
-                    <a:bodyPr/>
-                    <a:lstStyle/>
-                    <a:p>
-                      <a:pPr>
-                        <a:defRPr sz="1000">
-                          <a:solidFill>
-                            <a:srgbClr val="E0E0E0"/>
-                          </a:solidFill>
-                        </a:defRPr>
-                      </a:pPr>
-                      <a:r>
-                        <a:t>-</a:t>
-                      </a:r>
-                    </a:p>
-                  </a:txBody>
-                  <a:tcPr>
-                    <a:solidFill>
-                      <a:srgbClr val="1A1F2E"/>
-                    </a:solidFill>
-                  </a:tcPr>
-                </a:tc>
-                <a:tc>
-                  <a:txBody>
-                    <a:bodyPr/>
-                    <a:lstStyle/>
-                    <a:p>
-                      <a:pPr>
-                        <a:defRPr sz="1000">
-                          <a:solidFill>
-                            <a:srgbClr val="E0E0E0"/>
-                          </a:solidFill>
-                        </a:defRPr>
-                      </a:pPr>
-                      <a:r>
-                        <a:t>~$0.001</a:t>
-                      </a:r>
-                    </a:p>
-                  </a:txBody>
-                  <a:tcPr>
-                    <a:solidFill>
-                      <a:srgbClr val="1A1F2E"/>
-                    </a:solidFill>
-                  </a:tcPr>
-                </a:tc>
-                <a:tc>
-                  <a:txBody>
-                    <a:bodyPr/>
-                    <a:lstStyle/>
-                    <a:p>
-                      <a:pPr>
-                        <a:defRPr sz="1000">
-                          <a:solidFill>
-                            <a:srgbClr val="E0E0E0"/>
-                          </a:solidFill>
-                        </a:defRPr>
-                      </a:pPr>
-                      <a:r>
-                        <a:t>Ultra-low cost</a:t>
+                        <a:t>By Cargo</a:t>
+                      </a:r>
+                    </a:p>
+                  </a:txBody>
+                  <a:tcPr>
+                    <a:solidFill>
+                      <a:srgbClr val="1A1F2E"/>
+                    </a:solidFill>
+                  </a:tcPr>
+                </a:tc>
+                <a:tc>
+                  <a:txBody>
+                    <a:bodyPr/>
+                    <a:lstStyle/>
+                    <a:p>
+                      <a:pPr>
+                        <a:defRPr sz="1000">
+                          <a:solidFill>
+                            <a:srgbClr val="E0E0E0"/>
+                          </a:solidFill>
+                        </a:defRPr>
+                      </a:pPr>
+                      <a:r>
+                        <a:t>Commodity, HS Code, Container type, Weight</a:t>
                       </a:r>
                     </a:p>
                   </a:txBody>
@@ -5227,76 +5261,30 @@
                         </a:defRPr>
                       </a:pPr>
                       <a:r>
-                        <a:t>SAP posting time</a:t>
-                      </a:r>
-                    </a:p>
-                  </a:txBody>
-                  <a:tcPr>
-                    <a:solidFill>
-                      <a:srgbClr val="1A1F2E"/>
-                    </a:solidFill>
-                  </a:tcPr>
-                </a:tc>
-                <a:tc>
-                  <a:txBody>
-                    <a:bodyPr/>
-                    <a:lstStyle/>
-                    <a:p>
-                      <a:pPr>
-                        <a:defRPr sz="1000">
-                          <a:solidFill>
-                            <a:srgbClr val="E0E0E0"/>
-                          </a:solidFill>
-                        </a:defRPr>
-                      </a:pPr>
-                      <a:r>
-                        <a:t>Manual entry</a:t>
-                      </a:r>
-                    </a:p>
-                  </a:txBody>
-                  <a:tcPr>
-                    <a:solidFill>
-                      <a:srgbClr val="1A1F2E"/>
-                    </a:solidFill>
-                  </a:tcPr>
-                </a:tc>
-                <a:tc>
-                  <a:txBody>
-                    <a:bodyPr/>
-                    <a:lstStyle/>
-                    <a:p>
-                      <a:pPr>
-                        <a:defRPr sz="1000">
-                          <a:solidFill>
-                            <a:srgbClr val="E0E0E0"/>
-                          </a:solidFill>
-                        </a:defRPr>
-                      </a:pPr>
-                      <a:r>
-                        <a:t>Automatic</a:t>
-                      </a:r>
-                    </a:p>
-                  </a:txBody>
-                  <a:tcPr>
-                    <a:solidFill>
-                      <a:srgbClr val="1A1F2E"/>
-                    </a:solidFill>
-                  </a:tcPr>
-                </a:tc>
-                <a:tc>
-                  <a:txBody>
-                    <a:bodyPr/>
-                    <a:lstStyle/>
-                    <a:p>
-                      <a:pPr>
-                        <a:defRPr sz="1000">
-                          <a:solidFill>
-                            <a:srgbClr val="E0E0E0"/>
-                          </a:solidFill>
-                        </a:defRPr>
-                      </a:pPr>
-                      <a:r>
-                        <a:t>Zero manual work</a:t>
+                        <a:t>By Status</a:t>
+                      </a:r>
+                    </a:p>
+                  </a:txBody>
+                  <a:tcPr>
+                    <a:solidFill>
+                      <a:srgbClr val="1A1F2E"/>
+                    </a:solidFill>
+                  </a:tcPr>
+                </a:tc>
+                <a:tc>
+                  <a:txBody>
+                    <a:bodyPr/>
+                    <a:lstStyle/>
+                    <a:p>
+                      <a:pPr>
+                        <a:defRPr sz="1000">
+                          <a:solidFill>
+                            <a:srgbClr val="E0E0E0"/>
+                          </a:solidFill>
+                        </a:defRPr>
+                      </a:pPr>
+                      <a:r>
+                        <a:t>Document / Shipment / Compliance status</a:t>
                       </a:r>
                     </a:p>
                   </a:txBody>
@@ -5311,6 +5299,44 @@
           </a:graphicData>
         </a:graphic>
       </p:graphicFrame>
+      <p:sp>
+        <p:nvSpPr>
+          <p:cNvPr id="4" name="TextBox 3"/>
+          <p:cNvSpPr txBox="1"/>
+          <p:nvPr/>
+        </p:nvSpPr>
+        <p:spPr>
+          <a:xfrm>
+            <a:off x="731520" y="5029200"/>
+            <a:ext cx="7772400" cy="4572000"/>
+          </a:xfrm>
+          <a:prstGeom prst="rect">
+            <a:avLst/>
+          </a:prstGeom>
+          <a:noFill/>
+        </p:spPr>
+        <p:txBody>
+          <a:bodyPr wrap="square">
+            <a:spAutoFit/>
+          </a:bodyPr>
+          <a:lstStyle/>
+          <a:p>
+            <a:pPr>
+              <a:spcAft>
+                <a:spcPts val="600"/>
+              </a:spcAft>
+              <a:defRPr sz="1100" b="0">
+                <a:solidFill>
+                  <a:srgbClr val="999999"/>
+                </a:solidFill>
+              </a:defRPr>
+            </a:pPr>
+            <a:r>
+              <a:t>Domain: Incoterms 2020 | IMDG Code | VGM/SOLAS | Demurrage | L/C | Carrier Alliances | B/L Types</a:t>
+            </a:r>
+          </a:p>
+        </p:txBody>
+      </p:sp>
     </p:spTree>
   </p:cSld>
   <p:clrMapOvr>
@@ -5367,174 +5393,697 @@
               </a:defRPr>
             </a:pPr>
             <a:r>
-              <a:t>SAP S/4HANA Integration (Phase 4)</a:t>
-            </a:r>
-          </a:p>
-        </p:txBody>
-      </p:sp>
-      <p:sp>
-        <p:nvSpPr>
-          <p:cNvPr id="3" name="TextBox 2"/>
-          <p:cNvSpPr txBox="1"/>
+              <a:t>Business Impact</a:t>
+            </a:r>
+          </a:p>
+        </p:txBody>
+      </p:sp>
+      <p:graphicFrame>
+        <p:nvGraphicFramePr>
+          <p:cNvPr id="3" name="Table 2"/>
+          <p:cNvGraphicFramePr>
+            <a:graphicFrameLocks noGrp="1"/>
+          </p:cNvGraphicFramePr>
           <p:nvPr/>
-        </p:nvSpPr>
-        <p:spPr>
-          <a:xfrm>
-            <a:off x="731520" y="1371600"/>
-            <a:ext cx="7772400" cy="4572000"/>
-          </a:xfrm>
-          <a:prstGeom prst="rect">
-            <a:avLst/>
-          </a:prstGeom>
-          <a:noFill/>
-        </p:spPr>
-        <p:txBody>
-          <a:bodyPr wrap="square">
-            <a:spAutoFit/>
-          </a:bodyPr>
-          <a:lstStyle/>
-          <a:p>
-            <a:pPr>
-              <a:spcAft>
-                <a:spcPts val="600"/>
-              </a:spcAft>
-              <a:defRPr sz="1400" b="0">
-                <a:solidFill>
-                  <a:srgbClr val="FFFFFF"/>
-                </a:solidFill>
-              </a:defRPr>
-            </a:pPr>
-            <a:r>
-              <a:t>B/L Approved &gt; Automatic SAP Postings:</a:t>
-            </a:r>
-          </a:p>
-        </p:txBody>
-      </p:sp>
-      <p:sp>
-        <p:nvSpPr>
-          <p:cNvPr id="4" name="TextBox 3"/>
-          <p:cNvSpPr txBox="1"/>
-          <p:nvPr/>
-        </p:nvSpPr>
-        <p:spPr>
-          <a:xfrm>
-            <a:off x="731520" y="2286000"/>
-            <a:ext cx="7772400" cy="4572000"/>
-          </a:xfrm>
-          <a:prstGeom prst="rect">
-            <a:avLst/>
-          </a:prstGeom>
-          <a:noFill/>
-        </p:spPr>
-        <p:txBody>
-          <a:bodyPr wrap="square">
-            <a:spAutoFit/>
-          </a:bodyPr>
-          <a:lstStyle/>
-          <a:p>
-            <a:pPr>
-              <a:spcAft>
-                <a:spcPts val="800"/>
-              </a:spcAft>
-              <a:defRPr sz="1400">
-                <a:solidFill>
-                  <a:srgbClr val="E0E0E0"/>
-                </a:solidFill>
-              </a:defRPr>
-            </a:pPr>
-            <a:r>
-              <a:t>FI: Vendor Invoice (Debit Freight 4210000 / Credit AP 2100000)</a:t>
-            </a:r>
-          </a:p>
-          <a:p>
-            <a:pPr>
-              <a:spcAft>
-                <a:spcPts val="800"/>
-              </a:spcAft>
-              <a:defRPr sz="1400">
-                <a:solidFill>
-                  <a:srgbClr val="E0E0E0"/>
-                </a:solidFill>
-              </a:defRPr>
-            </a:pPr>
-            <a:r>
-              <a:t>MM: Goods Receipt (MIGO 101 &gt; Plant VF01, Storage WH01)</a:t>
-            </a:r>
-          </a:p>
-          <a:p>
-            <a:pPr>
-              <a:spcAft>
-                <a:spcPts val="800"/>
-              </a:spcAft>
-              <a:defRPr sz="1400">
-                <a:solidFill>
-                  <a:srgbClr val="E0E0E0"/>
-                </a:solidFill>
-              </a:defRPr>
-            </a:pPr>
-            <a:r>
-              <a:t>SD: Delivery + Billing (customer invoice generated)</a:t>
-            </a:r>
-          </a:p>
-          <a:p>
-            <a:pPr>
-              <a:spcAft>
-                <a:spcPts val="800"/>
-              </a:spcAft>
-              <a:defRPr sz="1400">
-                <a:solidFill>
-                  <a:srgbClr val="E0E0E0"/>
-                </a:solidFill>
-              </a:defRPr>
-            </a:pPr>
-            <a:r>
-              <a:t>CO: Cost Allocation (Ocean, THC, Doc Fee, BAF breakdown)</a:t>
-            </a:r>
-          </a:p>
-          <a:p>
-            <a:pPr>
-              <a:spcAft>
-                <a:spcPts val="800"/>
-              </a:spcAft>
-              <a:defRPr sz="1400">
-                <a:solidFill>
-                  <a:srgbClr val="E0E0E0"/>
-                </a:solidFill>
-              </a:defRPr>
-            </a:pPr>
-          </a:p>
-          <a:p>
-            <a:pPr>
-              <a:spcAft>
-                <a:spcPts val="800"/>
-              </a:spcAft>
-              <a:defRPr sz="1400">
-                <a:solidFill>
-                  <a:srgbClr val="E0E0E0"/>
-                </a:solidFill>
-              </a:defRPr>
-            </a:pPr>
-            <a:r>
-              <a:t>Current: SAP tables simulated in Snowflake (4 tables + 4 procedures)</a:t>
-            </a:r>
-          </a:p>
-          <a:p>
-            <a:pPr>
-              <a:spcAft>
-                <a:spcPts val="800"/>
-              </a:spcAft>
-              <a:defRPr sz="1400">
-                <a:solidFill>
-                  <a:srgbClr val="E0E0E0"/>
-                </a:solidFill>
-              </a:defRPr>
-            </a:pPr>
-            <a:r>
-              <a:t>Future: SAP No-Copy (Datasphere federation, zero ETL)</a:t>
-            </a:r>
-          </a:p>
-        </p:txBody>
-      </p:sp>
+        </p:nvGraphicFramePr>
+        <p:xfrm>
+          <a:off x="731520" y="1645920"/>
+          <a:ext cx="7772400" cy="2560320"/>
+        </p:xfrm>
+        <a:graphic>
+          <a:graphicData uri="http://schemas.openxmlformats.org/drawingml/2006/table">
+            <a:tbl>
+              <a:tblPr firstRow="1" bandRow="1">
+                <a:tableStyleId>{5C22544A-7EE6-4342-B048-85BDC9FD1C3A}</a:tableStyleId>
+              </a:tblPr>
+              <a:tblGrid>
+                <a:gridCol w="2286000"/>
+                <a:gridCol w="1828800"/>
+                <a:gridCol w="1828800"/>
+                <a:gridCol w="1828800"/>
+              </a:tblGrid>
+              <a:tr h="365760">
+                <a:tc>
+                  <a:txBody>
+                    <a:bodyPr/>
+                    <a:lstStyle/>
+                    <a:p>
+                      <a:pPr>
+                        <a:defRPr sz="1100" b="1">
+                          <a:solidFill>
+                            <a:srgbClr val="000000"/>
+                          </a:solidFill>
+                        </a:defRPr>
+                      </a:pPr>
+                      <a:r>
+                        <a:t>Metric</a:t>
+                      </a:r>
+                    </a:p>
+                  </a:txBody>
+                  <a:tcPr>
+                    <a:solidFill>
+                      <a:srgbClr val="29B5E8"/>
+                    </a:solidFill>
+                  </a:tcPr>
+                </a:tc>
+                <a:tc>
+                  <a:txBody>
+                    <a:bodyPr/>
+                    <a:lstStyle/>
+                    <a:p>
+                      <a:pPr>
+                        <a:defRPr sz="1100" b="1">
+                          <a:solidFill>
+                            <a:srgbClr val="000000"/>
+                          </a:solidFill>
+                        </a:defRPr>
+                      </a:pPr>
+                      <a:r>
+                        <a:t>Before</a:t>
+                      </a:r>
+                    </a:p>
+                  </a:txBody>
+                  <a:tcPr>
+                    <a:solidFill>
+                      <a:srgbClr val="29B5E8"/>
+                    </a:solidFill>
+                  </a:tcPr>
+                </a:tc>
+                <a:tc>
+                  <a:txBody>
+                    <a:bodyPr/>
+                    <a:lstStyle/>
+                    <a:p>
+                      <a:pPr>
+                        <a:defRPr sz="1100" b="1">
+                          <a:solidFill>
+                            <a:srgbClr val="000000"/>
+                          </a:solidFill>
+                        </a:defRPr>
+                      </a:pPr>
+                      <a:r>
+                        <a:t>After</a:t>
+                      </a:r>
+                    </a:p>
+                  </a:txBody>
+                  <a:tcPr>
+                    <a:solidFill>
+                      <a:srgbClr val="29B5E8"/>
+                    </a:solidFill>
+                  </a:tcPr>
+                </a:tc>
+                <a:tc>
+                  <a:txBody>
+                    <a:bodyPr/>
+                    <a:lstStyle/>
+                    <a:p>
+                      <a:pPr>
+                        <a:defRPr sz="1100" b="1">
+                          <a:solidFill>
+                            <a:srgbClr val="000000"/>
+                          </a:solidFill>
+                        </a:defRPr>
+                      </a:pPr>
+                      <a:r>
+                        <a:t>Improvement</a:t>
+                      </a:r>
+                    </a:p>
+                  </a:txBody>
+                  <a:tcPr>
+                    <a:solidFill>
+                      <a:srgbClr val="29B5E8"/>
+                    </a:solidFill>
+                  </a:tcPr>
+                </a:tc>
+              </a:tr>
+              <a:tr h="365760">
+                <a:tc>
+                  <a:txBody>
+                    <a:bodyPr/>
+                    <a:lstStyle/>
+                    <a:p>
+                      <a:pPr>
+                        <a:defRPr sz="1000">
+                          <a:solidFill>
+                            <a:srgbClr val="E0E0E0"/>
+                          </a:solidFill>
+                        </a:defRPr>
+                      </a:pPr>
+                      <a:r>
+                        <a:t>Classification time</a:t>
+                      </a:r>
+                    </a:p>
+                  </a:txBody>
+                  <a:tcPr>
+                    <a:solidFill>
+                      <a:srgbClr val="1A1F2E"/>
+                    </a:solidFill>
+                  </a:tcPr>
+                </a:tc>
+                <a:tc>
+                  <a:txBody>
+                    <a:bodyPr/>
+                    <a:lstStyle/>
+                    <a:p>
+                      <a:pPr>
+                        <a:defRPr sz="1000">
+                          <a:solidFill>
+                            <a:srgbClr val="E0E0E0"/>
+                          </a:solidFill>
+                        </a:defRPr>
+                      </a:pPr>
+                      <a:r>
+                        <a:t>15-30 min</a:t>
+                      </a:r>
+                    </a:p>
+                  </a:txBody>
+                  <a:tcPr>
+                    <a:solidFill>
+                      <a:srgbClr val="1A1F2E"/>
+                    </a:solidFill>
+                  </a:tcPr>
+                </a:tc>
+                <a:tc>
+                  <a:txBody>
+                    <a:bodyPr/>
+                    <a:lstStyle/>
+                    <a:p>
+                      <a:pPr>
+                        <a:defRPr sz="1000">
+                          <a:solidFill>
+                            <a:srgbClr val="E0E0E0"/>
+                          </a:solidFill>
+                        </a:defRPr>
+                      </a:pPr>
+                      <a:r>
+                        <a:t>2-3 sec</a:t>
+                      </a:r>
+                    </a:p>
+                  </a:txBody>
+                  <a:tcPr>
+                    <a:solidFill>
+                      <a:srgbClr val="1A1F2E"/>
+                    </a:solidFill>
+                  </a:tcPr>
+                </a:tc>
+                <a:tc>
+                  <a:txBody>
+                    <a:bodyPr/>
+                    <a:lstStyle/>
+                    <a:p>
+                      <a:pPr>
+                        <a:defRPr sz="1000">
+                          <a:solidFill>
+                            <a:srgbClr val="E0E0E0"/>
+                          </a:solidFill>
+                        </a:defRPr>
+                      </a:pPr>
+                      <a:r>
+                        <a:t>99.7% faster</a:t>
+                      </a:r>
+                    </a:p>
+                  </a:txBody>
+                  <a:tcPr>
+                    <a:solidFill>
+                      <a:srgbClr val="1A1F2E"/>
+                    </a:solidFill>
+                  </a:tcPr>
+                </a:tc>
+              </a:tr>
+              <a:tr h="365760">
+                <a:tc>
+                  <a:txBody>
+                    <a:bodyPr/>
+                    <a:lstStyle/>
+                    <a:p>
+                      <a:pPr>
+                        <a:defRPr sz="1000">
+                          <a:solidFill>
+                            <a:srgbClr val="E0E0E0"/>
+                          </a:solidFill>
+                        </a:defRPr>
+                      </a:pPr>
+                      <a:r>
+                        <a:t>Compliance coverage</a:t>
+                      </a:r>
+                    </a:p>
+                  </a:txBody>
+                  <a:tcPr>
+                    <a:solidFill>
+                      <a:srgbClr val="1A1F2E"/>
+                    </a:solidFill>
+                  </a:tcPr>
+                </a:tc>
+                <a:tc>
+                  <a:txBody>
+                    <a:bodyPr/>
+                    <a:lstStyle/>
+                    <a:p>
+                      <a:pPr>
+                        <a:defRPr sz="1000">
+                          <a:solidFill>
+                            <a:srgbClr val="E0E0E0"/>
+                          </a:solidFill>
+                        </a:defRPr>
+                      </a:pPr>
+                      <a:r>
+                        <a:t>60% manual</a:t>
+                      </a:r>
+                    </a:p>
+                  </a:txBody>
+                  <a:tcPr>
+                    <a:solidFill>
+                      <a:srgbClr val="1A1F2E"/>
+                    </a:solidFill>
+                  </a:tcPr>
+                </a:tc>
+                <a:tc>
+                  <a:txBody>
+                    <a:bodyPr/>
+                    <a:lstStyle/>
+                    <a:p>
+                      <a:pPr>
+                        <a:defRPr sz="1000">
+                          <a:solidFill>
+                            <a:srgbClr val="E0E0E0"/>
+                          </a:solidFill>
+                        </a:defRPr>
+                      </a:pPr>
+                      <a:r>
+                        <a:t>100% auto</a:t>
+                      </a:r>
+                    </a:p>
+                  </a:txBody>
+                  <a:tcPr>
+                    <a:solidFill>
+                      <a:srgbClr val="1A1F2E"/>
+                    </a:solidFill>
+                  </a:tcPr>
+                </a:tc>
+                <a:tc>
+                  <a:txBody>
+                    <a:bodyPr/>
+                    <a:lstStyle/>
+                    <a:p>
+                      <a:pPr>
+                        <a:defRPr sz="1000">
+                          <a:solidFill>
+                            <a:srgbClr val="E0E0E0"/>
+                          </a:solidFill>
+                        </a:defRPr>
+                      </a:pPr>
+                      <a:r>
+                        <a:t>Full coverage</a:t>
+                      </a:r>
+                    </a:p>
+                  </a:txBody>
+                  <a:tcPr>
+                    <a:solidFill>
+                      <a:srgbClr val="1A1F2E"/>
+                    </a:solidFill>
+                  </a:tcPr>
+                </a:tc>
+              </a:tr>
+              <a:tr h="365760">
+                <a:tc>
+                  <a:txBody>
+                    <a:bodyPr/>
+                    <a:lstStyle/>
+                    <a:p>
+                      <a:pPr>
+                        <a:defRPr sz="1000">
+                          <a:solidFill>
+                            <a:srgbClr val="E0E0E0"/>
+                          </a:solidFill>
+                        </a:defRPr>
+                      </a:pPr>
+                      <a:r>
+                        <a:t>Cross-check accuracy</a:t>
+                      </a:r>
+                    </a:p>
+                  </a:txBody>
+                  <a:tcPr>
+                    <a:solidFill>
+                      <a:srgbClr val="1A1F2E"/>
+                    </a:solidFill>
+                  </a:tcPr>
+                </a:tc>
+                <a:tc>
+                  <a:txBody>
+                    <a:bodyPr/>
+                    <a:lstStyle/>
+                    <a:p>
+                      <a:pPr>
+                        <a:defRPr sz="1000">
+                          <a:solidFill>
+                            <a:srgbClr val="E0E0E0"/>
+                          </a:solidFill>
+                        </a:defRPr>
+                      </a:pPr>
+                      <a:r>
+                        <a:t>Error-prone</a:t>
+                      </a:r>
+                    </a:p>
+                  </a:txBody>
+                  <a:tcPr>
+                    <a:solidFill>
+                      <a:srgbClr val="1A1F2E"/>
+                    </a:solidFill>
+                  </a:tcPr>
+                </a:tc>
+                <a:tc>
+                  <a:txBody>
+                    <a:bodyPr/>
+                    <a:lstStyle/>
+                    <a:p>
+                      <a:pPr>
+                        <a:defRPr sz="1000">
+                          <a:solidFill>
+                            <a:srgbClr val="E0E0E0"/>
+                          </a:solidFill>
+                        </a:defRPr>
+                      </a:pPr>
+                      <a:r>
+                        <a:t>Rule+AI hybrid</a:t>
+                      </a:r>
+                    </a:p>
+                  </a:txBody>
+                  <a:tcPr>
+                    <a:solidFill>
+                      <a:srgbClr val="1A1F2E"/>
+                    </a:solidFill>
+                  </a:tcPr>
+                </a:tc>
+                <a:tc>
+                  <a:txBody>
+                    <a:bodyPr/>
+                    <a:lstStyle/>
+                    <a:p>
+                      <a:pPr>
+                        <a:defRPr sz="1000">
+                          <a:solidFill>
+                            <a:srgbClr val="E0E0E0"/>
+                          </a:solidFill>
+                        </a:defRPr>
+                      </a:pPr>
+                      <a:r>
+                        <a:t>Zero missed</a:t>
+                      </a:r>
+                    </a:p>
+                  </a:txBody>
+                  <a:tcPr>
+                    <a:solidFill>
+                      <a:srgbClr val="1A1F2E"/>
+                    </a:solidFill>
+                  </a:tcPr>
+                </a:tc>
+              </a:tr>
+              <a:tr h="365760">
+                <a:tc>
+                  <a:txBody>
+                    <a:bodyPr/>
+                    <a:lstStyle/>
+                    <a:p>
+                      <a:pPr>
+                        <a:defRPr sz="1000">
+                          <a:solidFill>
+                            <a:srgbClr val="E0E0E0"/>
+                          </a:solidFill>
+                        </a:defRPr>
+                      </a:pPr>
+                      <a:r>
+                        <a:t>Fraud detection</a:t>
+                      </a:r>
+                    </a:p>
+                  </a:txBody>
+                  <a:tcPr>
+                    <a:solidFill>
+                      <a:srgbClr val="1A1F2E"/>
+                    </a:solidFill>
+                  </a:tcPr>
+                </a:tc>
+                <a:tc>
+                  <a:txBody>
+                    <a:bodyPr/>
+                    <a:lstStyle/>
+                    <a:p>
+                      <a:pPr>
+                        <a:defRPr sz="1000">
+                          <a:solidFill>
+                            <a:srgbClr val="E0E0E0"/>
+                          </a:solidFill>
+                        </a:defRPr>
+                      </a:pPr>
+                      <a:r>
+                        <a:t>Reactive</a:t>
+                      </a:r>
+                    </a:p>
+                  </a:txBody>
+                  <a:tcPr>
+                    <a:solidFill>
+                      <a:srgbClr val="1A1F2E"/>
+                    </a:solidFill>
+                  </a:tcPr>
+                </a:tc>
+                <a:tc>
+                  <a:txBody>
+                    <a:bodyPr/>
+                    <a:lstStyle/>
+                    <a:p>
+                      <a:pPr>
+                        <a:defRPr sz="1000">
+                          <a:solidFill>
+                            <a:srgbClr val="E0E0E0"/>
+                          </a:solidFill>
+                        </a:defRPr>
+                      </a:pPr>
+                      <a:r>
+                        <a:t>Proactive</a:t>
+                      </a:r>
+                    </a:p>
+                  </a:txBody>
+                  <a:tcPr>
+                    <a:solidFill>
+                      <a:srgbClr val="1A1F2E"/>
+                    </a:solidFill>
+                  </a:tcPr>
+                </a:tc>
+                <a:tc>
+                  <a:txBody>
+                    <a:bodyPr/>
+                    <a:lstStyle/>
+                    <a:p>
+                      <a:pPr>
+                        <a:defRPr sz="1000">
+                          <a:solidFill>
+                            <a:srgbClr val="E0E0E0"/>
+                          </a:solidFill>
+                        </a:defRPr>
+                      </a:pPr>
+                      <a:r>
+                        <a:t>Early detection</a:t>
+                      </a:r>
+                    </a:p>
+                  </a:txBody>
+                  <a:tcPr>
+                    <a:solidFill>
+                      <a:srgbClr val="1A1F2E"/>
+                    </a:solidFill>
+                  </a:tcPr>
+                </a:tc>
+              </a:tr>
+              <a:tr h="365760">
+                <a:tc>
+                  <a:txBody>
+                    <a:bodyPr/>
+                    <a:lstStyle/>
+                    <a:p>
+                      <a:pPr>
+                        <a:defRPr sz="1000">
+                          <a:solidFill>
+                            <a:srgbClr val="E0E0E0"/>
+                          </a:solidFill>
+                        </a:defRPr>
+                      </a:pPr>
+                      <a:r>
+                        <a:t>AI cost per document</a:t>
+                      </a:r>
+                    </a:p>
+                  </a:txBody>
+                  <a:tcPr>
+                    <a:solidFill>
+                      <a:srgbClr val="1A1F2E"/>
+                    </a:solidFill>
+                  </a:tcPr>
+                </a:tc>
+                <a:tc>
+                  <a:txBody>
+                    <a:bodyPr/>
+                    <a:lstStyle/>
+                    <a:p>
+                      <a:pPr>
+                        <a:defRPr sz="1000">
+                          <a:solidFill>
+                            <a:srgbClr val="E0E0E0"/>
+                          </a:solidFill>
+                        </a:defRPr>
+                      </a:pPr>
+                      <a:r>
+                        <a:t>-</a:t>
+                      </a:r>
+                    </a:p>
+                  </a:txBody>
+                  <a:tcPr>
+                    <a:solidFill>
+                      <a:srgbClr val="1A1F2E"/>
+                    </a:solidFill>
+                  </a:tcPr>
+                </a:tc>
+                <a:tc>
+                  <a:txBody>
+                    <a:bodyPr/>
+                    <a:lstStyle/>
+                    <a:p>
+                      <a:pPr>
+                        <a:defRPr sz="1000">
+                          <a:solidFill>
+                            <a:srgbClr val="E0E0E0"/>
+                          </a:solidFill>
+                        </a:defRPr>
+                      </a:pPr>
+                      <a:r>
+                        <a:t>~$0.001</a:t>
+                      </a:r>
+                    </a:p>
+                  </a:txBody>
+                  <a:tcPr>
+                    <a:solidFill>
+                      <a:srgbClr val="1A1F2E"/>
+                    </a:solidFill>
+                  </a:tcPr>
+                </a:tc>
+                <a:tc>
+                  <a:txBody>
+                    <a:bodyPr/>
+                    <a:lstStyle/>
+                    <a:p>
+                      <a:pPr>
+                        <a:defRPr sz="1000">
+                          <a:solidFill>
+                            <a:srgbClr val="E0E0E0"/>
+                          </a:solidFill>
+                        </a:defRPr>
+                      </a:pPr>
+                      <a:r>
+                        <a:t>Ultra-low cost</a:t>
+                      </a:r>
+                    </a:p>
+                  </a:txBody>
+                  <a:tcPr>
+                    <a:solidFill>
+                      <a:srgbClr val="1A1F2E"/>
+                    </a:solidFill>
+                  </a:tcPr>
+                </a:tc>
+              </a:tr>
+              <a:tr h="365760">
+                <a:tc>
+                  <a:txBody>
+                    <a:bodyPr/>
+                    <a:lstStyle/>
+                    <a:p>
+                      <a:pPr>
+                        <a:defRPr sz="1000">
+                          <a:solidFill>
+                            <a:srgbClr val="E0E0E0"/>
+                          </a:solidFill>
+                        </a:defRPr>
+                      </a:pPr>
+                      <a:r>
+                        <a:t>SAP posting time</a:t>
+                      </a:r>
+                    </a:p>
+                  </a:txBody>
+                  <a:tcPr>
+                    <a:solidFill>
+                      <a:srgbClr val="1A1F2E"/>
+                    </a:solidFill>
+                  </a:tcPr>
+                </a:tc>
+                <a:tc>
+                  <a:txBody>
+                    <a:bodyPr/>
+                    <a:lstStyle/>
+                    <a:p>
+                      <a:pPr>
+                        <a:defRPr sz="1000">
+                          <a:solidFill>
+                            <a:srgbClr val="E0E0E0"/>
+                          </a:solidFill>
+                        </a:defRPr>
+                      </a:pPr>
+                      <a:r>
+                        <a:t>Manual entry</a:t>
+                      </a:r>
+                    </a:p>
+                  </a:txBody>
+                  <a:tcPr>
+                    <a:solidFill>
+                      <a:srgbClr val="1A1F2E"/>
+                    </a:solidFill>
+                  </a:tcPr>
+                </a:tc>
+                <a:tc>
+                  <a:txBody>
+                    <a:bodyPr/>
+                    <a:lstStyle/>
+                    <a:p>
+                      <a:pPr>
+                        <a:defRPr sz="1000">
+                          <a:solidFill>
+                            <a:srgbClr val="E0E0E0"/>
+                          </a:solidFill>
+                        </a:defRPr>
+                      </a:pPr>
+                      <a:r>
+                        <a:t>Automatic</a:t>
+                      </a:r>
+                    </a:p>
+                  </a:txBody>
+                  <a:tcPr>
+                    <a:solidFill>
+                      <a:srgbClr val="1A1F2E"/>
+                    </a:solidFill>
+                  </a:tcPr>
+                </a:tc>
+                <a:tc>
+                  <a:txBody>
+                    <a:bodyPr/>
+                    <a:lstStyle/>
+                    <a:p>
+                      <a:pPr>
+                        <a:defRPr sz="1000">
+                          <a:solidFill>
+                            <a:srgbClr val="E0E0E0"/>
+                          </a:solidFill>
+                        </a:defRPr>
+                      </a:pPr>
+                      <a:r>
+                        <a:t>Zero manual work</a:t>
+                      </a:r>
+                    </a:p>
+                  </a:txBody>
+                  <a:tcPr>
+                    <a:solidFill>
+                      <a:srgbClr val="1A1F2E"/>
+                    </a:solidFill>
+                  </a:tcPr>
+                </a:tc>
+              </a:tr>
+            </a:tbl>
+          </a:graphicData>
+        </a:graphic>
+      </p:graphicFrame>
     </p:spTree>
   </p:cSld>
   <p:clrMapOvr>
@@ -5591,6 +6140,230 @@
               </a:defRPr>
             </a:pPr>
             <a:r>
+              <a:t>SAP S/4HANA Integration (Phase 4)</a:t>
+            </a:r>
+          </a:p>
+        </p:txBody>
+      </p:sp>
+      <p:sp>
+        <p:nvSpPr>
+          <p:cNvPr id="3" name="TextBox 2"/>
+          <p:cNvSpPr txBox="1"/>
+          <p:nvPr/>
+        </p:nvSpPr>
+        <p:spPr>
+          <a:xfrm>
+            <a:off x="731520" y="1371600"/>
+            <a:ext cx="7772400" cy="4572000"/>
+          </a:xfrm>
+          <a:prstGeom prst="rect">
+            <a:avLst/>
+          </a:prstGeom>
+          <a:noFill/>
+        </p:spPr>
+        <p:txBody>
+          <a:bodyPr wrap="square">
+            <a:spAutoFit/>
+          </a:bodyPr>
+          <a:lstStyle/>
+          <a:p>
+            <a:pPr>
+              <a:spcAft>
+                <a:spcPts val="600"/>
+              </a:spcAft>
+              <a:defRPr sz="1400" b="0">
+                <a:solidFill>
+                  <a:srgbClr val="FFFFFF"/>
+                </a:solidFill>
+              </a:defRPr>
+            </a:pPr>
+            <a:r>
+              <a:t>B/L Approved &gt; Automatic SAP Postings:</a:t>
+            </a:r>
+          </a:p>
+        </p:txBody>
+      </p:sp>
+      <p:sp>
+        <p:nvSpPr>
+          <p:cNvPr id="4" name="TextBox 3"/>
+          <p:cNvSpPr txBox="1"/>
+          <p:nvPr/>
+        </p:nvSpPr>
+        <p:spPr>
+          <a:xfrm>
+            <a:off x="731520" y="2286000"/>
+            <a:ext cx="7772400" cy="4572000"/>
+          </a:xfrm>
+          <a:prstGeom prst="rect">
+            <a:avLst/>
+          </a:prstGeom>
+          <a:noFill/>
+        </p:spPr>
+        <p:txBody>
+          <a:bodyPr wrap="square">
+            <a:spAutoFit/>
+          </a:bodyPr>
+          <a:lstStyle/>
+          <a:p>
+            <a:pPr>
+              <a:spcAft>
+                <a:spcPts val="800"/>
+              </a:spcAft>
+              <a:defRPr sz="1400">
+                <a:solidFill>
+                  <a:srgbClr val="E0E0E0"/>
+                </a:solidFill>
+              </a:defRPr>
+            </a:pPr>
+            <a:r>
+              <a:t>FI: Vendor Invoice (Debit Freight 4210000 / Credit AP 2100000)</a:t>
+            </a:r>
+          </a:p>
+          <a:p>
+            <a:pPr>
+              <a:spcAft>
+                <a:spcPts val="800"/>
+              </a:spcAft>
+              <a:defRPr sz="1400">
+                <a:solidFill>
+                  <a:srgbClr val="E0E0E0"/>
+                </a:solidFill>
+              </a:defRPr>
+            </a:pPr>
+            <a:r>
+              <a:t>MM: Goods Receipt (MIGO 101 &gt; Plant VF01, Storage WH01)</a:t>
+            </a:r>
+          </a:p>
+          <a:p>
+            <a:pPr>
+              <a:spcAft>
+                <a:spcPts val="800"/>
+              </a:spcAft>
+              <a:defRPr sz="1400">
+                <a:solidFill>
+                  <a:srgbClr val="E0E0E0"/>
+                </a:solidFill>
+              </a:defRPr>
+            </a:pPr>
+            <a:r>
+              <a:t>SD: Delivery + Billing (customer invoice generated)</a:t>
+            </a:r>
+          </a:p>
+          <a:p>
+            <a:pPr>
+              <a:spcAft>
+                <a:spcPts val="800"/>
+              </a:spcAft>
+              <a:defRPr sz="1400">
+                <a:solidFill>
+                  <a:srgbClr val="E0E0E0"/>
+                </a:solidFill>
+              </a:defRPr>
+            </a:pPr>
+            <a:r>
+              <a:t>CO: Cost Allocation (Ocean, THC, Doc Fee, BAF breakdown)</a:t>
+            </a:r>
+          </a:p>
+          <a:p>
+            <a:pPr>
+              <a:spcAft>
+                <a:spcPts val="800"/>
+              </a:spcAft>
+              <a:defRPr sz="1400">
+                <a:solidFill>
+                  <a:srgbClr val="E0E0E0"/>
+                </a:solidFill>
+              </a:defRPr>
+            </a:pPr>
+          </a:p>
+          <a:p>
+            <a:pPr>
+              <a:spcAft>
+                <a:spcPts val="800"/>
+              </a:spcAft>
+              <a:defRPr sz="1400">
+                <a:solidFill>
+                  <a:srgbClr val="E0E0E0"/>
+                </a:solidFill>
+              </a:defRPr>
+            </a:pPr>
+            <a:r>
+              <a:t>Current: SAP tables simulated in Snowflake (4 tables + 4 procedures)</a:t>
+            </a:r>
+          </a:p>
+          <a:p>
+            <a:pPr>
+              <a:spcAft>
+                <a:spcPts val="800"/>
+              </a:spcAft>
+              <a:defRPr sz="1400">
+                <a:solidFill>
+                  <a:srgbClr val="E0E0E0"/>
+                </a:solidFill>
+              </a:defRPr>
+            </a:pPr>
+            <a:r>
+              <a:t>Future: SAP No-Copy (Datasphere federation, zero ETL)</a:t>
+            </a:r>
+          </a:p>
+        </p:txBody>
+      </p:sp>
+    </p:spTree>
+  </p:cSld>
+  <p:clrMapOvr>
+    <a:masterClrMapping/>
+  </p:clrMapOvr>
+</p:sld>
+</file>
+
+<file path=ppt/slides/slide17.xml><?xml version="1.0" encoding="utf-8"?>
+<p:sld xmlns:a="http://schemas.openxmlformats.org/drawingml/2006/main" xmlns:p="http://schemas.openxmlformats.org/presentationml/2006/main" xmlns:r="http://schemas.openxmlformats.org/officeDocument/2006/relationships">
+  <p:cSld>
+    <p:bg>
+      <p:bgPr>
+        <a:solidFill>
+          <a:srgbClr val="0F1117"/>
+        </a:solidFill>
+        <a:effectLst/>
+      </p:bgPr>
+    </p:bg>
+    <p:spTree>
+      <p:nvGrpSpPr>
+        <p:cNvPr id="1" name=""/>
+        <p:cNvGrpSpPr/>
+        <p:nvPr/>
+      </p:nvGrpSpPr>
+      <p:grpSpPr/>
+      <p:sp>
+        <p:nvSpPr>
+          <p:cNvPr id="2" name="TextBox 1"/>
+          <p:cNvSpPr txBox="1"/>
+          <p:nvPr/>
+        </p:nvSpPr>
+        <p:spPr>
+          <a:xfrm>
+            <a:off x="731520" y="457200"/>
+            <a:ext cx="7772400" cy="731520"/>
+          </a:xfrm>
+          <a:prstGeom prst="rect">
+            <a:avLst/>
+          </a:prstGeom>
+          <a:noFill/>
+        </p:spPr>
+        <p:txBody>
+          <a:bodyPr wrap="square">
+            <a:spAutoFit/>
+          </a:bodyPr>
+          <a:lstStyle/>
+          <a:p>
+            <a:pPr>
+              <a:defRPr sz="3200" b="1">
+                <a:solidFill>
+                  <a:srgbClr val="29B5E8"/>
+                </a:solidFill>
+              </a:defRPr>
+            </a:pPr>
+            <a:r>
               <a:t>Live Demo &amp; Roadmap</a:t>
             </a:r>
           </a:p>
@@ -5757,7 +6530,7 @@
         </p:nvGraphicFramePr>
         <p:xfrm>
           <a:off x="731520" y="4572000"/>
-          <a:ext cx="7315200" cy="1828800"/>
+          <a:ext cx="7315200" cy="2194560"/>
         </p:xfrm>
         <a:graphic>
           <a:graphicData uri="http://schemas.openxmlformats.org/drawingml/2006/table">
@@ -6125,6 +6898,77 @@
                   </a:tcPr>
                 </a:tc>
               </a:tr>
+              <a:tr h="365760">
+                <a:tc>
+                  <a:txBody>
+                    <a:bodyPr/>
+                    <a:lstStyle/>
+                    <a:p>
+                      <a:pPr>
+                        <a:defRPr sz="1000">
+                          <a:solidFill>
+                            <a:srgbClr val="E0E0E0"/>
+                          </a:solidFill>
+                        </a:defRPr>
+                      </a:pPr>
+                      <a:r>
+                        <a:t>Phase 5</a:t>
+                      </a:r>
+                    </a:p>
+                  </a:txBody>
+                  <a:tcPr>
+                    <a:solidFill>
+                      <a:srgbClr val="1A1F2E"/>
+                    </a:solidFill>
+                  </a:tcPr>
+                </a:tc>
+                <a:tc>
+                  <a:txBody>
+                    <a:bodyPr/>
+                    <a:lstStyle/>
+                    <a:p>
+                      <a:pPr>
+                        <a:defRPr sz="1000">
+                          <a:solidFill>
+                            <a:srgbClr val="E0E0E0"/>
+                          </a:solidFill>
+                        </a:defRPr>
+                      </a:pPr>
+                      <a:r>
+                        <a:t>Multi-Tenant Data Isolation</a:t>
+                      </a:r>
+                    </a:p>
+                  </a:txBody>
+                  <a:tcPr>
+                    <a:solidFill>
+                      <a:srgbClr val="1A1F2E"/>
+                    </a:solidFill>
+                  </a:tcPr>
+                </a:tc>
+                <a:tc>
+                  <a:txBody>
+                    <a:bodyPr/>
+                    <a:lstStyle/>
+                    <a:p>
+                      <a:pPr>
+                        <a:defRPr sz="1000">
+                          <a:solidFill>
+                            <a:srgbClr val="E0E0E0"/>
+                          </a:solidFill>
+                        </a:defRPr>
+                      </a:pPr>
+                      <a:r>
+                        <a:t>Planned</a:t>
+                      </a:r>
+                    </a:p>
+                  </a:txBody>
+                  <a:tcPr>
+                    <a:solidFill>
+                      <a:srgbClr val="1A1F2E"/>
+                    </a:solidFill>
+                  </a:tcPr>
+                </a:tc>
+              </a:tr>
             </a:tbl>
           </a:graphicData>
         </a:graphic>
@@ -6137,7 +6981,7 @@
 </p:sld>
 </file>
 
-<file path=ppt/slides/slide17.xml><?xml version="1.0" encoding="utf-8"?>
+<file path=ppt/slides/slide18.xml><?xml version="1.0" encoding="utf-8"?>
 <p:sld xmlns:a="http://schemas.openxmlformats.org/drawingml/2006/main" xmlns:p="http://schemas.openxmlformats.org/presentationml/2006/main" xmlns:r="http://schemas.openxmlformats.org/officeDocument/2006/relationships">
   <p:cSld>
     <p:bg>
@@ -6890,7 +7734,7 @@
               </a:defRPr>
             </a:pPr>
             <a:r>
-              <a:t>Solution: AI Document Intelligence Pipeline</a:t>
+              <a:t>Solution: Automated Workflow Pipeline</a:t>
             </a:r>
           </a:p>
         </p:txBody>
@@ -6928,7 +7772,7 @@
               </a:defRPr>
             </a:pPr>
             <a:r>
-              <a:t>Upload &gt; Auto-Classify &gt; Extract &gt; Cross-Check &gt; Compliance &gt; Fraud Scan</a:t>
+              <a:t>Upload &gt; Classify &gt; Cross-Check &gt; Compliance &gt; Fraud Scan &gt; SAP Post</a:t>
             </a:r>
           </a:p>
           <a:p>
@@ -6943,7 +7787,7 @@
               </a:defRPr>
             </a:pPr>
             <a:r>
-              <a:t>(Mendix)   (Cortex AI)    (AI_PARSE)   (Rule+AI)      (SQL Rules)     (Pattern)</a:t>
+              <a:t>(Mendix)   (Cortex AI)  (Rule+AI)      (SQL Rules)    (Pattern)     (Auto)</a:t>
             </a:r>
           </a:p>
         </p:txBody>
@@ -6956,7 +7800,7 @@
         </p:nvSpPr>
         <p:spPr>
           <a:xfrm>
-            <a:off x="731520" y="2743200"/>
+            <a:off x="731520" y="2560320"/>
             <a:ext cx="7772400" cy="4572000"/>
           </a:xfrm>
           <a:prstGeom prst="rect">
@@ -6972,18 +7816,41 @@
           <a:p>
             <a:pPr>
               <a:spcAft>
-                <a:spcPts val="800"/>
+                <a:spcPts val="600"/>
               </a:spcAft>
-              <a:defRPr sz="1500">
-                <a:solidFill>
-                  <a:srgbClr val="E0E0E0"/>
-                </a:solidFill>
-              </a:defRPr>
-            </a:pPr>
-            <a:r>
-              <a:t>Zero-hallucination architecture for financial/logistics data</a:t>
-            </a:r>
-          </a:p>
+              <a:defRPr sz="1800" b="1">
+                <a:solidFill>
+                  <a:srgbClr val="22C55E"/>
+                </a:solidFill>
+              </a:defRPr>
+            </a:pPr>
+            <a:r>
+              <a:t>KEY: IT TAKES ACTION</a:t>
+            </a:r>
+          </a:p>
+        </p:txBody>
+      </p:sp>
+      <p:sp>
+        <p:nvSpPr>
+          <p:cNvPr id="5" name="TextBox 4"/>
+          <p:cNvSpPr txBox="1"/>
+          <p:nvPr/>
+        </p:nvSpPr>
+        <p:spPr>
+          <a:xfrm>
+            <a:off x="731520" y="3200400"/>
+            <a:ext cx="7772400" cy="4572000"/>
+          </a:xfrm>
+          <a:prstGeom prst="rect">
+            <a:avLst/>
+          </a:prstGeom>
+          <a:noFill/>
+        </p:spPr>
+        <p:txBody>
+          <a:bodyPr wrap="square">
+            <a:spAutoFit/>
+          </a:bodyPr>
+          <a:lstStyle/>
           <a:p>
             <a:pPr>
               <a:spcAft>
@@ -6996,7 +7863,7 @@
               </a:defRPr>
             </a:pPr>
             <a:r>
-              <a:t>Hybrid AI: Rules first (free), AI only for edge cases</a:t>
+              <a:t>Not a dashboard. It classifies, validates, blocks, and posts — automatically</a:t>
             </a:r>
           </a:p>
           <a:p>
@@ -7011,7 +7878,7 @@
               </a:defRPr>
             </a:pPr>
             <a:r>
-              <a:t>Real-time compliance against 138 HS codes + DG classification</a:t>
+              <a:t>Zero-hallucination: deterministic procedures for financial data</a:t>
             </a:r>
           </a:p>
           <a:p>
@@ -7026,7 +7893,22 @@
               </a:defRPr>
             </a:pPr>
             <a:r>
-              <a:t>Fraud detection with 5 algorithmic rules (pure SQL, instant)</a:t>
+              <a:t>Hybrid AI: rules first (free), AI only for edge cases (90% savings)</a:t>
+            </a:r>
+          </a:p>
+          <a:p>
+            <a:pPr>
+              <a:spcAft>
+                <a:spcPts val="800"/>
+              </a:spcAft>
+              <a:defRPr sz="1500">
+                <a:solidFill>
+                  <a:srgbClr val="E0E0E0"/>
+                </a:solidFill>
+              </a:defRPr>
+            </a:pPr>
+            <a:r>
+              <a:t>End-to-end: document to SAP posting, fully automated</a:t>
             </a:r>
           </a:p>
           <a:p>

</xml_diff>